<commit_message>
Redraw feature mockups as perspective laptop with phone in front
Silver laptop rendered in perspective (screen warp, keyboard deck, trackpad)
with a front-facing phone overlapping at the lower right; deck slide 13
rebuilt with the new images.

Generated with [Devin](https://devin.ai)

Co-Authored-By: Devin <158243242+devin-ai-integration[bot]@users.noreply.github.com>
</commit_message>
<xml_diff>
--- a/docs/presentation/nomadpick.pptx
+++ b/docs/presentation/nomadpick.pptx
@@ -165,7 +165,7 @@
     </p:spTree>
     <p:extLst>
       <p:ext uri="{BB962C8B-B14F-4D97-AF65-F5344CB8AC3E}">
-        <p14:creationId xmlns:p14="http://schemas.microsoft.com/office/powerpoint/2010/main" val="3212975176"/>
+        <p14:creationId xmlns:p14="http://schemas.microsoft.com/office/powerpoint/2010/main" val="1854040843"/>
       </p:ext>
     </p:extLst>
   </p:cSld>
@@ -12335,8 +12335,8 @@
         </p:blipFill>
         <p:spPr>
           <a:xfrm>
-            <a:off x="1700569" y="1325880"/>
-            <a:ext cx="3151909" cy="2080259"/>
+            <a:off x="1644947" y="1325880"/>
+            <a:ext cx="3263152" cy="2080259"/>
           </a:xfrm>
           <a:prstGeom prst="rect">
             <a:avLst/>
@@ -12389,8 +12389,8 @@
         </p:blipFill>
         <p:spPr>
           <a:xfrm>
-            <a:off x="7339216" y="1325880"/>
-            <a:ext cx="3151909" cy="2080259"/>
+            <a:off x="7283594" y="1325880"/>
+            <a:ext cx="3263152" cy="2080259"/>
           </a:xfrm>
           <a:prstGeom prst="rect">
             <a:avLst/>
@@ -12443,8 +12443,8 @@
         </p:blipFill>
         <p:spPr>
           <a:xfrm>
-            <a:off x="1700569" y="3909060"/>
-            <a:ext cx="3151909" cy="2080259"/>
+            <a:off x="1644947" y="3909060"/>
+            <a:ext cx="3263152" cy="2080259"/>
           </a:xfrm>
           <a:prstGeom prst="rect">
             <a:avLst/>
@@ -12497,8 +12497,8 @@
         </p:blipFill>
         <p:spPr>
           <a:xfrm>
-            <a:off x="7339216" y="3909060"/>
-            <a:ext cx="3151909" cy="2080259"/>
+            <a:off x="7283594" y="3909060"/>
+            <a:ext cx="3263152" cy="2080259"/>
           </a:xfrm>
           <a:prstGeom prst="rect">
             <a:avLst/>

</xml_diff>

<commit_message>
Use official Apple product bezels for responsive mockups
Mockups now place real captures (1512x982@2x, 402x874@3x) inside Apple
Design Resources bezels (MacBook Pro M5 14, iPhone 17 Pro), varying color
and arrangement per scene without altering the frames. Bezel dmgs are
downloaded and extracted with 7-Zip into the ignored docs/tools/out/bezels.
Deck slide 13 rebuilt; credit added to the Pages footer.

Generated with [Devin](https://devin.ai)

Co-Authored-By: Devin <158243242+devin-ai-integration[bot]@users.noreply.github.com>
</commit_message>
<xml_diff>
--- a/docs/presentation/nomadpick.pptx
+++ b/docs/presentation/nomadpick.pptx
@@ -165,7 +165,7 @@
     </p:spTree>
     <p:extLst>
       <p:ext uri="{BB962C8B-B14F-4D97-AF65-F5344CB8AC3E}">
-        <p14:creationId xmlns:p14="http://schemas.microsoft.com/office/powerpoint/2010/main" val="1854040843"/>
+        <p14:creationId xmlns:p14="http://schemas.microsoft.com/office/powerpoint/2010/main" val="711200953"/>
       </p:ext>
     </p:extLst>
   </p:cSld>
@@ -12335,8 +12335,8 @@
         </p:blipFill>
         <p:spPr>
           <a:xfrm>
-            <a:off x="1644947" y="1325880"/>
-            <a:ext cx="3263152" cy="2080259"/>
+            <a:off x="1603953" y="1325880"/>
+            <a:ext cx="3345141" cy="2080259"/>
           </a:xfrm>
           <a:prstGeom prst="rect">
             <a:avLst/>
@@ -12389,8 +12389,8 @@
         </p:blipFill>
         <p:spPr>
           <a:xfrm>
-            <a:off x="7283594" y="1325880"/>
-            <a:ext cx="3263152" cy="2080259"/>
+            <a:off x="6997880" y="1325880"/>
+            <a:ext cx="3834580" cy="2080259"/>
           </a:xfrm>
           <a:prstGeom prst="rect">
             <a:avLst/>
@@ -12443,8 +12443,8 @@
         </p:blipFill>
         <p:spPr>
           <a:xfrm>
-            <a:off x="1644947" y="3909060"/>
-            <a:ext cx="3263152" cy="2080259"/>
+            <a:off x="1204035" y="3909060"/>
+            <a:ext cx="4144976" cy="2080259"/>
           </a:xfrm>
           <a:prstGeom prst="rect">
             <a:avLst/>
@@ -12497,8 +12497,8 @@
         </p:blipFill>
         <p:spPr>
           <a:xfrm>
-            <a:off x="7283594" y="3909060"/>
-            <a:ext cx="3263152" cy="2080259"/>
+            <a:off x="7072194" y="3909060"/>
+            <a:ext cx="3685953" cy="2080259"/>
           </a:xfrm>
           <a:prstGeom prst="rect">
             <a:avLst/>

</xml_diff>